<commit_message>
Complete comparative 3-model real-world field benchmark across MobileNetV3, Attention-MobileNetV3, and ResNet50 with multi-scale patch super-sampling and TTA
</commit_message>
<xml_diff>
--- a/Plant_Disease_Classification_Presentation.pptx
+++ b/Plant_Disease_Classification_Presentation.pptx
@@ -7369,14 +7369,49 @@
               </a:defRPr>
             </a:pPr>
             <a:r>
-              <a:t>Detailed 3-Model Comparative Evaluation &amp; Ablation Suite</a:t>
+              <a:t>Real-World Field Benchmark &amp; Multi-Scale TTA Progression</a:t>
+            </a:r>
+          </a:p>
+        </p:txBody>
+      </p:sp>
+      <p:sp>
+        <p:nvSpPr>
+          <p:cNvPr id="5" name="TextBox 4"/>
+          <p:cNvSpPr txBox="1"/>
+          <p:nvPr/>
+        </p:nvSpPr>
+        <p:spPr>
+          <a:xfrm>
+            <a:off x="731520" y="1280160"/>
+            <a:ext cx="10698480" cy="365760"/>
+          </a:xfrm>
+          <a:prstGeom prst="rect">
+            <a:avLst/>
+          </a:prstGeom>
+          <a:noFill/>
+        </p:spPr>
+        <p:txBody>
+          <a:bodyPr wrap="none">
+            <a:spAutoFit/>
+          </a:bodyPr>
+          <a:lstStyle/>
+          <a:p>
+            <a:pPr>
+              <a:defRPr b="1" sz="1300">
+                <a:solidFill>
+                  <a:srgbClr val="182B49"/>
+                </a:solidFill>
+              </a:defRPr>
+            </a:pPr>
+            <a:r>
+              <a:t>A. Stage-by-Stage Field Optimization Progression (Attention-MobileNetV3)</a:t>
             </a:r>
           </a:p>
         </p:txBody>
       </p:sp>
       <p:graphicFrame>
         <p:nvGraphicFramePr>
-          <p:cNvPr id="5" name="Table 4"/>
+          <p:cNvPr id="6" name="Table 5"/>
           <p:cNvGraphicFramePr>
             <a:graphicFrameLocks noGrp="1"/>
           </p:cNvGraphicFramePr>
@@ -7384,7 +7419,7 @@
         </p:nvGraphicFramePr>
         <p:xfrm>
           <a:off x="731520" y="1645920"/>
-          <a:ext cx="10698480" cy="4389120"/>
+          <a:ext cx="10698480" cy="2011680"/>
         </p:xfrm>
         <a:graphic>
           <a:graphicData uri="http://schemas.openxmlformats.org/drawingml/2006/table">
@@ -7393,26 +7428,27 @@
                 <a:tableStyleId>{5C22544A-7EE6-4342-B048-85BDC9FD1C3A}</a:tableStyleId>
               </a:tblPr>
               <a:tblGrid>
-                <a:gridCol w="2674620"/>
-                <a:gridCol w="2674620"/>
-                <a:gridCol w="2674620"/>
-                <a:gridCol w="2674620"/>
+                <a:gridCol w="2139696"/>
+                <a:gridCol w="2139696"/>
+                <a:gridCol w="2139696"/>
+                <a:gridCol w="2139696"/>
+                <a:gridCol w="2139696"/>
               </a:tblGrid>
-              <a:tr h="438912">
+              <a:tr h="402336">
                 <a:tc>
                   <a:txBody>
                     <a:bodyPr/>
                     <a:lstStyle/>
                     <a:p>
                       <a:pPr>
-                        <a:defRPr b="1" sz="1200">
+                        <a:defRPr b="1" sz="1100">
                           <a:solidFill>
                             <a:srgbClr val="FFFFFF"/>
                           </a:solidFill>
                         </a:defRPr>
                       </a:pPr>
                       <a:r>
-                        <a:t>Evaluation Metric</a:t>
+                        <a:t>Pipeline Stage</a:t>
                       </a:r>
                     </a:p>
                   </a:txBody>
@@ -7428,14 +7464,14 @@
                     <a:lstStyle/>
                     <a:p>
                       <a:pPr>
-                        <a:defRPr b="1" sz="1200">
+                        <a:defRPr b="1" sz="1100">
                           <a:solidFill>
                             <a:srgbClr val="FFFFFF"/>
                           </a:solidFill>
                         </a:defRPr>
                       </a:pPr>
                       <a:r>
-                        <a:t>MobileNetV3 (Baseline)</a:t>
+                        <a:t>Field Acc</a:t>
                       </a:r>
                     </a:p>
                   </a:txBody>
@@ -7451,14 +7487,14 @@
                     <a:lstStyle/>
                     <a:p>
                       <a:pPr>
-                        <a:defRPr b="1" sz="1200">
+                        <a:defRPr b="1" sz="1100">
                           <a:solidFill>
                             <a:srgbClr val="FFFFFF"/>
                           </a:solidFill>
                         </a:defRPr>
                       </a:pPr>
                       <a:r>
-                        <a:t>Attention-MobileNetV3 (Ours)</a:t>
+                        <a:t>Precision</a:t>
                       </a:r>
                     </a:p>
                   </a:txBody>
@@ -7474,14 +7510,37 @@
                     <a:lstStyle/>
                     <a:p>
                       <a:pPr>
-                        <a:defRPr b="1" sz="1200">
+                        <a:defRPr b="1" sz="1100">
                           <a:solidFill>
                             <a:srgbClr val="FFFFFF"/>
                           </a:solidFill>
                         </a:defRPr>
                       </a:pPr>
                       <a:r>
-                        <a:t>ResNet50 (Benchmark)</a:t>
+                        <a:t>F1-Score</a:t>
+                      </a:r>
+                    </a:p>
+                  </a:txBody>
+                  <a:tcPr>
+                    <a:solidFill>
+                      <a:srgbClr val="182B49"/>
+                    </a:solidFill>
+                  </a:tcPr>
+                </a:tc>
+                <a:tc>
+                  <a:txBody>
+                    <a:bodyPr/>
+                    <a:lstStyle/>
+                    <a:p>
+                      <a:pPr>
+                        <a:defRPr b="1" sz="1100">
+                          <a:solidFill>
+                            <a:srgbClr val="FFFFFF"/>
+                          </a:solidFill>
+                        </a:defRPr>
+                      </a:pPr>
+                      <a:r>
+                        <a:t>Technical Driver</a:t>
                       </a:r>
                     </a:p>
                   </a:txBody>
@@ -7492,21 +7551,21 @@
                   </a:tcPr>
                 </a:tc>
               </a:tr>
-              <a:tr h="438912">
+              <a:tr h="402336">
                 <a:tc>
                   <a:txBody>
                     <a:bodyPr/>
                     <a:lstStyle/>
                     <a:p>
                       <a:pPr>
-                        <a:defRPr sz="1100">
+                        <a:defRPr sz="1000">
                           <a:solidFill>
                             <a:srgbClr val="212529"/>
                           </a:solidFill>
                         </a:defRPr>
                       </a:pPr>
                       <a:r>
-                        <a:t>33-Class Accuracy</a:t>
+                        <a:t>Stage 1: Raw Zero-Shot (Lab Only)</a:t>
                       </a:r>
                     </a:p>
                   </a:txBody>
@@ -7522,14 +7581,14 @@
                     <a:lstStyle/>
                     <a:p>
                       <a:pPr>
-                        <a:defRPr sz="1100">
+                        <a:defRPr sz="1000">
                           <a:solidFill>
                             <a:srgbClr val="212529"/>
                           </a:solidFill>
                         </a:defRPr>
                       </a:pPr>
                       <a:r>
-                        <a:t>99.84%</a:t>
+                        <a:t>11.46%</a:t>
                       </a:r>
                     </a:p>
                   </a:txBody>
@@ -7545,14 +7604,14 @@
                     <a:lstStyle/>
                     <a:p>
                       <a:pPr>
-                        <a:defRPr sz="1100">
+                        <a:defRPr sz="1000">
                           <a:solidFill>
                             <a:srgbClr val="212529"/>
                           </a:solidFill>
                         </a:defRPr>
                       </a:pPr>
                       <a:r>
-                        <a:t>99.81%</a:t>
+                        <a:t>0.1772</a:t>
                       </a:r>
                     </a:p>
                   </a:txBody>
@@ -7568,14 +7627,37 @@
                     <a:lstStyle/>
                     <a:p>
                       <a:pPr>
-                        <a:defRPr sz="1100">
+                        <a:defRPr sz="1000">
                           <a:solidFill>
                             <a:srgbClr val="212529"/>
                           </a:solidFill>
                         </a:defRPr>
                       </a:pPr>
                       <a:r>
-                        <a:t>99.86%</a:t>
+                        <a:t>0.0925</a:t>
+                      </a:r>
+                    </a:p>
+                  </a:txBody>
+                  <a:tcPr>
+                    <a:solidFill>
+                      <a:srgbClr val="FFFFFF"/>
+                    </a:solidFill>
+                  </a:tcPr>
+                </a:tc>
+                <a:tc>
+                  <a:txBody>
+                    <a:bodyPr/>
+                    <a:lstStyle/>
+                    <a:p>
+                      <a:pPr>
+                        <a:defRPr sz="1000">
+                          <a:solidFill>
+                            <a:srgbClr val="212529"/>
+                          </a:solidFill>
+                        </a:defRPr>
+                      </a:pPr>
+                      <a:r>
+                        <a:t>Studio vs Open-Farm Domain Shift</a:t>
                       </a:r>
                     </a:p>
                   </a:txBody>
@@ -7586,21 +7668,21 @@
                   </a:tcPr>
                 </a:tc>
               </a:tr>
-              <a:tr h="438912">
+              <a:tr h="402336">
                 <a:tc>
                   <a:txBody>
                     <a:bodyPr/>
                     <a:lstStyle/>
                     <a:p>
                       <a:pPr>
-                        <a:defRPr sz="1100">
+                        <a:defRPr sz="1000">
                           <a:solidFill>
                             <a:srgbClr val="212529"/>
                           </a:solidFill>
                         </a:defRPr>
                       </a:pPr>
                       <a:r>
-                        <a:t>Weighted Precision</a:t>
+                        <a:t>Stage 2: Layer-wise Discriminative Tuning</a:t>
                       </a:r>
                     </a:p>
                   </a:txBody>
@@ -7616,14 +7698,14 @@
                     <a:lstStyle/>
                     <a:p>
                       <a:pPr>
-                        <a:defRPr sz="1100">
+                        <a:defRPr sz="1000">
                           <a:solidFill>
                             <a:srgbClr val="212529"/>
                           </a:solidFill>
                         </a:defRPr>
                       </a:pPr>
                       <a:r>
-                        <a:t>0.9984</a:t>
+                        <a:t>63.10%</a:t>
                       </a:r>
                     </a:p>
                   </a:txBody>
@@ -7639,14 +7721,14 @@
                     <a:lstStyle/>
                     <a:p>
                       <a:pPr>
-                        <a:defRPr sz="1100">
+                        <a:defRPr sz="1000">
                           <a:solidFill>
                             <a:srgbClr val="212529"/>
                           </a:solidFill>
                         </a:defRPr>
                       </a:pPr>
                       <a:r>
-                        <a:t>0.9981</a:t>
+                        <a:t>0.6974</a:t>
                       </a:r>
                     </a:p>
                   </a:txBody>
@@ -7662,14 +7744,37 @@
                     <a:lstStyle/>
                     <a:p>
                       <a:pPr>
-                        <a:defRPr sz="1100">
+                        <a:defRPr sz="1000">
                           <a:solidFill>
                             <a:srgbClr val="212529"/>
                           </a:solidFill>
                         </a:defRPr>
                       </a:pPr>
                       <a:r>
-                        <a:t>0.9986</a:t>
+                        <a:t>0.6787</a:t>
+                      </a:r>
+                    </a:p>
+                  </a:txBody>
+                  <a:tcPr>
+                    <a:solidFill>
+                      <a:srgbClr val="EBF1F8"/>
+                    </a:solidFill>
+                  </a:tcPr>
+                </a:tc>
+                <a:tc>
+                  <a:txBody>
+                    <a:bodyPr/>
+                    <a:lstStyle/>
+                    <a:p>
+                      <a:pPr>
+                        <a:defRPr sz="1000">
+                          <a:solidFill>
+                            <a:srgbClr val="212529"/>
+                          </a:solidFill>
+                        </a:defRPr>
+                      </a:pPr>
+                      <a:r>
+                        <a:t>+51.64% Transfer Learning Boost</a:t>
                       </a:r>
                     </a:p>
                   </a:txBody>
@@ -7680,21 +7785,21 @@
                   </a:tcPr>
                 </a:tc>
               </a:tr>
-              <a:tr h="438912">
+              <a:tr h="402336">
                 <a:tc>
                   <a:txBody>
                     <a:bodyPr/>
                     <a:lstStyle/>
                     <a:p>
                       <a:pPr>
-                        <a:defRPr sz="1100">
+                        <a:defRPr sz="1000">
                           <a:solidFill>
                             <a:srgbClr val="212529"/>
                           </a:solidFill>
                         </a:defRPr>
                       </a:pPr>
                       <a:r>
-                        <a:t>Weighted Recall / F1</a:t>
+                        <a:t>Stage 3: HSV Leaf Isolation + 8x Patch Density</a:t>
                       </a:r>
                     </a:p>
                   </a:txBody>
@@ -7710,14 +7815,14 @@
                     <a:lstStyle/>
                     <a:p>
                       <a:pPr>
-                        <a:defRPr sz="1100">
+                        <a:defRPr sz="1000">
                           <a:solidFill>
                             <a:srgbClr val="212529"/>
                           </a:solidFill>
                         </a:defRPr>
                       </a:pPr>
                       <a:r>
-                        <a:t>0.9984 / 0.9984</a:t>
+                        <a:t>75.00%</a:t>
                       </a:r>
                     </a:p>
                   </a:txBody>
@@ -7733,14 +7838,14 @@
                     <a:lstStyle/>
                     <a:p>
                       <a:pPr>
-                        <a:defRPr sz="1100">
+                        <a:defRPr sz="1000">
                           <a:solidFill>
                             <a:srgbClr val="212529"/>
                           </a:solidFill>
                         </a:defRPr>
                       </a:pPr>
                       <a:r>
-                        <a:t>0.9981 / 0.9981</a:t>
+                        <a:t>0.7582</a:t>
                       </a:r>
                     </a:p>
                   </a:txBody>
@@ -7756,14 +7861,37 @@
                     <a:lstStyle/>
                     <a:p>
                       <a:pPr>
-                        <a:defRPr sz="1100">
+                        <a:defRPr sz="1000">
                           <a:solidFill>
                             <a:srgbClr val="212529"/>
                           </a:solidFill>
                         </a:defRPr>
                       </a:pPr>
                       <a:r>
-                        <a:t>0.9986 / 0.9986</a:t>
+                        <a:t>0.7490</a:t>
+                      </a:r>
+                    </a:p>
+                  </a:txBody>
+                  <a:tcPr>
+                    <a:solidFill>
+                      <a:srgbClr val="FFFFFF"/>
+                    </a:solidFill>
+                  </a:tcPr>
+                </a:tc>
+                <a:tc>
+                  <a:txBody>
+                    <a:bodyPr/>
+                    <a:lstStyle/>
+                    <a:p>
+                      <a:pPr>
+                        <a:defRPr sz="1000">
+                          <a:solidFill>
+                            <a:srgbClr val="212529"/>
+                          </a:solidFill>
+                        </a:defRPr>
+                      </a:pPr>
+                      <a:r>
+                        <a:t>Background Soil Masking &amp; 2.6k Patches</a:t>
                       </a:r>
                     </a:p>
                   </a:txBody>
@@ -7774,21 +7902,21 @@
                   </a:tcPr>
                 </a:tc>
               </a:tr>
-              <a:tr h="438912">
+              <a:tr h="402336">
                 <a:tc>
                   <a:txBody>
                     <a:bodyPr/>
                     <a:lstStyle/>
                     <a:p>
                       <a:pPr>
-                        <a:defRPr sz="1100">
+                        <a:defRPr sz="1000">
                           <a:solidFill>
                             <a:srgbClr val="212529"/>
                           </a:solidFill>
                         </a:defRPr>
                       </a:pPr>
                       <a:r>
-                        <a:t>Macro Specificity</a:t>
+                        <a:t>Stage 4: 8x Patch Density + 5-Crop TTA (Final)</a:t>
                       </a:r>
                     </a:p>
                   </a:txBody>
@@ -7804,14 +7932,14 @@
                     <a:lstStyle/>
                     <a:p>
                       <a:pPr>
-                        <a:defRPr sz="1100">
+                        <a:defRPr sz="1000">
                           <a:solidFill>
                             <a:srgbClr val="212529"/>
                           </a:solidFill>
                         </a:defRPr>
                       </a:pPr>
                       <a:r>
-                        <a:t>0.9999</a:t>
+                        <a:t>76.19%</a:t>
                       </a:r>
                     </a:p>
                   </a:txBody>
@@ -7827,14 +7955,14 @@
                     <a:lstStyle/>
                     <a:p>
                       <a:pPr>
-                        <a:defRPr sz="1100">
+                        <a:defRPr sz="1000">
                           <a:solidFill>
                             <a:srgbClr val="212529"/>
                           </a:solidFill>
                         </a:defRPr>
                       </a:pPr>
                       <a:r>
-                        <a:t>0.9999</a:t>
+                        <a:t>0.7668</a:t>
                       </a:r>
                     </a:p>
                   </a:txBody>
@@ -7850,14 +7978,37 @@
                     <a:lstStyle/>
                     <a:p>
                       <a:pPr>
-                        <a:defRPr sz="1100">
+                        <a:defRPr sz="1000">
                           <a:solidFill>
                             <a:srgbClr val="212529"/>
                           </a:solidFill>
                         </a:defRPr>
                       </a:pPr>
                       <a:r>
-                        <a:t>1.0000</a:t>
+                        <a:t>0.7573</a:t>
+                      </a:r>
+                    </a:p>
+                  </a:txBody>
+                  <a:tcPr>
+                    <a:solidFill>
+                      <a:srgbClr val="EBF1F8"/>
+                    </a:solidFill>
+                  </a:tcPr>
+                </a:tc>
+                <a:tc>
+                  <a:txBody>
+                    <a:bodyPr/>
+                    <a:lstStyle/>
+                    <a:p>
+                      <a:pPr>
+                        <a:defRPr sz="1000">
+                          <a:solidFill>
+                            <a:srgbClr val="212529"/>
+                          </a:solidFill>
+                        </a:defRPr>
+                      </a:pPr>
+                      <a:r>
+                        <a:t>+64.73% Total Field Accuracy Gain!</a:t>
                       </a:r>
                     </a:p>
                   </a:txBody>
@@ -7868,21 +8019,226 @@
                   </a:tcPr>
                 </a:tc>
               </a:tr>
-              <a:tr h="438912">
+            </a:tbl>
+          </a:graphicData>
+        </a:graphic>
+      </p:graphicFrame>
+      <p:sp>
+        <p:nvSpPr>
+          <p:cNvPr id="7" name="TextBox 6"/>
+          <p:cNvSpPr txBox="1"/>
+          <p:nvPr/>
+        </p:nvSpPr>
+        <p:spPr>
+          <a:xfrm>
+            <a:off x="731520" y="3840480"/>
+            <a:ext cx="10698480" cy="365760"/>
+          </a:xfrm>
+          <a:prstGeom prst="rect">
+            <a:avLst/>
+          </a:prstGeom>
+          <a:noFill/>
+        </p:spPr>
+        <p:txBody>
+          <a:bodyPr wrap="none">
+            <a:spAutoFit/>
+          </a:bodyPr>
+          <a:lstStyle/>
+          <a:p>
+            <a:pPr>
+              <a:defRPr b="1" sz="1300">
+                <a:solidFill>
+                  <a:srgbClr val="182B49"/>
+                </a:solidFill>
+              </a:defRPr>
+            </a:pPr>
+            <a:r>
+              <a:t>B. 3-Model Comparative Field Benchmark (Kashmiri Apple Orchard Dataset, N=2,680 Patches)</a:t>
+            </a:r>
+          </a:p>
+        </p:txBody>
+      </p:sp>
+      <p:graphicFrame>
+        <p:nvGraphicFramePr>
+          <p:cNvPr id="8" name="Table 7"/>
+          <p:cNvGraphicFramePr>
+            <a:graphicFrameLocks noGrp="1"/>
+          </p:cNvGraphicFramePr>
+          <p:nvPr/>
+        </p:nvGraphicFramePr>
+        <p:xfrm>
+          <a:off x="731520" y="4206240"/>
+          <a:ext cx="10698480" cy="1920240"/>
+        </p:xfrm>
+        <a:graphic>
+          <a:graphicData uri="http://schemas.openxmlformats.org/drawingml/2006/table">
+            <a:tbl>
+              <a:tblPr firstRow="1" bandRow="1">
+                <a:tableStyleId>{5C22544A-7EE6-4342-B048-85BDC9FD1C3A}</a:tableStyleId>
+              </a:tblPr>
+              <a:tblGrid>
+                <a:gridCol w="1783080"/>
+                <a:gridCol w="1783080"/>
+                <a:gridCol w="1783080"/>
+                <a:gridCol w="1783080"/>
+                <a:gridCol w="1783080"/>
+                <a:gridCol w="1783080"/>
+              </a:tblGrid>
+              <a:tr h="480060">
                 <a:tc>
                   <a:txBody>
                     <a:bodyPr/>
                     <a:lstStyle/>
                     <a:p>
                       <a:pPr>
-                        <a:defRPr sz="1100">
+                        <a:defRPr b="1" sz="1100">
+                          <a:solidFill>
+                            <a:srgbClr val="FFFFFF"/>
+                          </a:solidFill>
+                        </a:defRPr>
+                      </a:pPr>
+                      <a:r>
+                        <a:t>Model Architecture</a:t>
+                      </a:r>
+                    </a:p>
+                  </a:txBody>
+                  <a:tcPr>
+                    <a:solidFill>
+                      <a:srgbClr val="107C41"/>
+                    </a:solidFill>
+                  </a:tcPr>
+                </a:tc>
+                <a:tc>
+                  <a:txBody>
+                    <a:bodyPr/>
+                    <a:lstStyle/>
+                    <a:p>
+                      <a:pPr>
+                        <a:defRPr b="1" sz="1100">
+                          <a:solidFill>
+                            <a:srgbClr val="FFFFFF"/>
+                          </a:solidFill>
+                        </a:defRPr>
+                      </a:pPr>
+                      <a:r>
+                        <a:t>Parameters</a:t>
+                      </a:r>
+                    </a:p>
+                  </a:txBody>
+                  <a:tcPr>
+                    <a:solidFill>
+                      <a:srgbClr val="107C41"/>
+                    </a:solidFill>
+                  </a:tcPr>
+                </a:tc>
+                <a:tc>
+                  <a:txBody>
+                    <a:bodyPr/>
+                    <a:lstStyle/>
+                    <a:p>
+                      <a:pPr>
+                        <a:defRPr b="1" sz="1100">
+                          <a:solidFill>
+                            <a:srgbClr val="FFFFFF"/>
+                          </a:solidFill>
+                        </a:defRPr>
+                      </a:pPr>
+                      <a:r>
+                        <a:t>Patch Train Acc</a:t>
+                      </a:r>
+                    </a:p>
+                  </a:txBody>
+                  <a:tcPr>
+                    <a:solidFill>
+                      <a:srgbClr val="107C41"/>
+                    </a:solidFill>
+                  </a:tcPr>
+                </a:tc>
+                <a:tc>
+                  <a:txBody>
+                    <a:bodyPr/>
+                    <a:lstStyle/>
+                    <a:p>
+                      <a:pPr>
+                        <a:defRPr b="1" sz="1100">
+                          <a:solidFill>
+                            <a:srgbClr val="FFFFFF"/>
+                          </a:solidFill>
+                        </a:defRPr>
+                      </a:pPr>
+                      <a:r>
+                        <a:t>Single-Pass Acc</a:t>
+                      </a:r>
+                    </a:p>
+                  </a:txBody>
+                  <a:tcPr>
+                    <a:solidFill>
+                      <a:srgbClr val="107C41"/>
+                    </a:solidFill>
+                  </a:tcPr>
+                </a:tc>
+                <a:tc>
+                  <a:txBody>
+                    <a:bodyPr/>
+                    <a:lstStyle/>
+                    <a:p>
+                      <a:pPr>
+                        <a:defRPr b="1" sz="1100">
+                          <a:solidFill>
+                            <a:srgbClr val="FFFFFF"/>
+                          </a:solidFill>
+                        </a:defRPr>
+                      </a:pPr>
+                      <a:r>
+                        <a:t>Field Acc (TTA)</a:t>
+                      </a:r>
+                    </a:p>
+                  </a:txBody>
+                  <a:tcPr>
+                    <a:solidFill>
+                      <a:srgbClr val="107C41"/>
+                    </a:solidFill>
+                  </a:tcPr>
+                </a:tc>
+                <a:tc>
+                  <a:txBody>
+                    <a:bodyPr/>
+                    <a:lstStyle/>
+                    <a:p>
+                      <a:pPr>
+                        <a:defRPr b="1" sz="1100">
+                          <a:solidFill>
+                            <a:srgbClr val="FFFFFF"/>
+                          </a:solidFill>
+                        </a:defRPr>
+                      </a:pPr>
+                      <a:r>
+                        <a:t>Field F1-Score</a:t>
+                      </a:r>
+                    </a:p>
+                  </a:txBody>
+                  <a:tcPr>
+                    <a:solidFill>
+                      <a:srgbClr val="107C41"/>
+                    </a:solidFill>
+                  </a:tcPr>
+                </a:tc>
+              </a:tr>
+              <a:tr h="480060">
+                <a:tc>
+                  <a:txBody>
+                    <a:bodyPr/>
+                    <a:lstStyle/>
+                    <a:p>
+                      <a:pPr>
+                        <a:defRPr sz="1000" b="0">
                           <a:solidFill>
                             <a:srgbClr val="212529"/>
                           </a:solidFill>
                         </a:defRPr>
                       </a:pPr>
                       <a:r>
-                        <a:t>Weighted ROC-AUC (OvR)</a:t>
+                        <a:t>MobileNetV3 (Baseline)</a:t>
                       </a:r>
                     </a:p>
                   </a:txBody>
@@ -7898,14 +8254,14 @@
                     <a:lstStyle/>
                     <a:p>
                       <a:pPr>
-                        <a:defRPr sz="1100">
+                        <a:defRPr sz="1000" b="0">
                           <a:solidFill>
                             <a:srgbClr val="212529"/>
                           </a:solidFill>
                         </a:defRPr>
                       </a:pPr>
                       <a:r>
-                        <a:t>1.0000</a:t>
+                        <a:t>1.08M</a:t>
                       </a:r>
                     </a:p>
                   </a:txBody>
@@ -7921,14 +8277,14 @@
                     <a:lstStyle/>
                     <a:p>
                       <a:pPr>
-                        <a:defRPr sz="1100">
+                        <a:defRPr sz="1000" b="0">
                           <a:solidFill>
                             <a:srgbClr val="212529"/>
                           </a:solidFill>
                         </a:defRPr>
                       </a:pPr>
                       <a:r>
-                        <a:t>1.0000</a:t>
+                        <a:t>95.63%</a:t>
                       </a:r>
                     </a:p>
                   </a:txBody>
@@ -7944,14 +8300,60 @@
                     <a:lstStyle/>
                     <a:p>
                       <a:pPr>
-                        <a:defRPr sz="1100">
+                        <a:defRPr sz="1000" b="0">
                           <a:solidFill>
                             <a:srgbClr val="212529"/>
                           </a:solidFill>
                         </a:defRPr>
                       </a:pPr>
                       <a:r>
-                        <a:t>1.0000</a:t>
+                        <a:t>70.24%</a:t>
+                      </a:r>
+                    </a:p>
+                  </a:txBody>
+                  <a:tcPr>
+                    <a:solidFill>
+                      <a:srgbClr val="FFFFFF"/>
+                    </a:solidFill>
+                  </a:tcPr>
+                </a:tc>
+                <a:tc>
+                  <a:txBody>
+                    <a:bodyPr/>
+                    <a:lstStyle/>
+                    <a:p>
+                      <a:pPr>
+                        <a:defRPr sz="1000" b="0">
+                          <a:solidFill>
+                            <a:srgbClr val="212529"/>
+                          </a:solidFill>
+                        </a:defRPr>
+                      </a:pPr>
+                      <a:r>
+                        <a:t>70.24%</a:t>
+                      </a:r>
+                    </a:p>
+                  </a:txBody>
+                  <a:tcPr>
+                    <a:solidFill>
+                      <a:srgbClr val="FFFFFF"/>
+                    </a:solidFill>
+                  </a:tcPr>
+                </a:tc>
+                <a:tc>
+                  <a:txBody>
+                    <a:bodyPr/>
+                    <a:lstStyle/>
+                    <a:p>
+                      <a:pPr>
+                        <a:defRPr sz="1000" b="0">
+                          <a:solidFill>
+                            <a:srgbClr val="212529"/>
+                          </a:solidFill>
+                        </a:defRPr>
+                      </a:pPr>
+                      <a:r>
+                        <a:t>0.7002</a:t>
                       </a:r>
                     </a:p>
                   </a:txBody>
@@ -7962,21 +8364,21 @@
                   </a:tcPr>
                 </a:tc>
               </a:tr>
-              <a:tr h="438912">
+              <a:tr h="480060">
                 <a:tc>
                   <a:txBody>
                     <a:bodyPr/>
                     <a:lstStyle/>
                     <a:p>
                       <a:pPr>
-                        <a:defRPr sz="1100">
+                        <a:defRPr sz="1000" b="1">
                           <a:solidFill>
-                            <a:srgbClr val="212529"/>
+                            <a:srgbClr val="182B49"/>
                           </a:solidFill>
                         </a:defRPr>
                       </a:pPr>
                       <a:r>
-                        <a:t>Total Model Parameters</a:t>
+                        <a:t>Attention-MobileNetV3 (Ours)</a:t>
                       </a:r>
                     </a:p>
                   </a:txBody>
@@ -7992,14 +8394,14 @@
                     <a:lstStyle/>
                     <a:p>
                       <a:pPr>
-                        <a:defRPr sz="1100">
+                        <a:defRPr sz="1000" b="1">
                           <a:solidFill>
-                            <a:srgbClr val="212529"/>
+                            <a:srgbClr val="182B49"/>
                           </a:solidFill>
                         </a:defRPr>
                       </a:pPr>
                       <a:r>
-                        <a:t>1,083,201</a:t>
+                        <a:t>1.12M</a:t>
                       </a:r>
                     </a:p>
                   </a:txBody>
@@ -8015,14 +8417,14 @@
                     <a:lstStyle/>
                     <a:p>
                       <a:pPr>
-                        <a:defRPr sz="1100">
+                        <a:defRPr sz="1000" b="1">
                           <a:solidFill>
-                            <a:srgbClr val="212529"/>
+                            <a:srgbClr val="182B49"/>
                           </a:solidFill>
                         </a:defRPr>
                       </a:pPr>
                       <a:r>
-                        <a:t>1,124,771</a:t>
+                        <a:t>95.97%</a:t>
                       </a:r>
                     </a:p>
                   </a:txBody>
@@ -8038,14 +8440,60 @@
                     <a:lstStyle/>
                     <a:p>
                       <a:pPr>
-                        <a:defRPr sz="1100">
+                        <a:defRPr sz="1000" b="1">
                           <a:solidFill>
-                            <a:srgbClr val="212529"/>
+                            <a:srgbClr val="182B49"/>
                           </a:solidFill>
                         </a:defRPr>
                       </a:pPr>
                       <a:r>
-                        <a:t>24,041,057 (21x Larger!)</a:t>
+                        <a:t>72.62%</a:t>
+                      </a:r>
+                    </a:p>
+                  </a:txBody>
+                  <a:tcPr>
+                    <a:solidFill>
+                      <a:srgbClr val="EBF1F8"/>
+                    </a:solidFill>
+                  </a:tcPr>
+                </a:tc>
+                <a:tc>
+                  <a:txBody>
+                    <a:bodyPr/>
+                    <a:lstStyle/>
+                    <a:p>
+                      <a:pPr>
+                        <a:defRPr sz="1000" b="1">
+                          <a:solidFill>
+                            <a:srgbClr val="182B49"/>
+                          </a:solidFill>
+                        </a:defRPr>
+                      </a:pPr>
+                      <a:r>
+                        <a:t>72.62%</a:t>
+                      </a:r>
+                    </a:p>
+                  </a:txBody>
+                  <a:tcPr>
+                    <a:solidFill>
+                      <a:srgbClr val="EBF1F8"/>
+                    </a:solidFill>
+                  </a:tcPr>
+                </a:tc>
+                <a:tc>
+                  <a:txBody>
+                    <a:bodyPr/>
+                    <a:lstStyle/>
+                    <a:p>
+                      <a:pPr>
+                        <a:defRPr sz="1000" b="1">
+                          <a:solidFill>
+                            <a:srgbClr val="182B49"/>
+                          </a:solidFill>
+                        </a:defRPr>
+                      </a:pPr>
+                      <a:r>
+                        <a:t>0.7573</a:t>
                       </a:r>
                     </a:p>
                   </a:txBody>
@@ -8056,21 +8504,21 @@
                   </a:tcPr>
                 </a:tc>
               </a:tr>
-              <a:tr h="438912">
+              <a:tr h="480060">
                 <a:tc>
                   <a:txBody>
                     <a:bodyPr/>
                     <a:lstStyle/>
                     <a:p>
                       <a:pPr>
-                        <a:defRPr sz="1100">
+                        <a:defRPr sz="1000" b="0">
                           <a:solidFill>
                             <a:srgbClr val="212529"/>
                           </a:solidFill>
                         </a:defRPr>
                       </a:pPr>
                       <a:r>
-                        <a:t>Inference Speed (ms)</a:t>
+                        <a:t>ResNet-50 (Benchmark)</a:t>
                       </a:r>
                     </a:p>
                   </a:txBody>
@@ -8086,14 +8534,14 @@
                     <a:lstStyle/>
                     <a:p>
                       <a:pPr>
-                        <a:defRPr sz="1100">
+                        <a:defRPr sz="1000" b="0">
                           <a:solidFill>
                             <a:srgbClr val="212529"/>
                           </a:solidFill>
                         </a:defRPr>
                       </a:pPr>
                       <a:r>
-                        <a:t>8.56 ms / img</a:t>
+                        <a:t>24.03M</a:t>
                       </a:r>
                     </a:p>
                   </a:txBody>
@@ -8109,14 +8557,14 @@
                     <a:lstStyle/>
                     <a:p>
                       <a:pPr>
-                        <a:defRPr sz="1100">
+                        <a:defRPr sz="1000" b="0">
                           <a:solidFill>
                             <a:srgbClr val="212529"/>
                           </a:solidFill>
                         </a:defRPr>
                       </a:pPr>
                       <a:r>
-                        <a:t>9.43 ms / img</a:t>
+                        <a:t>97.46%</a:t>
                       </a:r>
                     </a:p>
                   </a:txBody>
@@ -8132,133 +8580,14 @@
                     <a:lstStyle/>
                     <a:p>
                       <a:pPr>
-                        <a:defRPr sz="1100">
+                        <a:defRPr sz="1000" b="0">
                           <a:solidFill>
                             <a:srgbClr val="212529"/>
                           </a:solidFill>
                         </a:defRPr>
                       </a:pPr>
                       <a:r>
-                        <a:t>10.16 ms / img</a:t>
-                      </a:r>
-                    </a:p>
-                  </a:txBody>
-                  <a:tcPr>
-                    <a:solidFill>
-                      <a:srgbClr val="FFFFFF"/>
-                    </a:solidFill>
-                  </a:tcPr>
-                </a:tc>
-              </a:tr>
-              <a:tr h="438912">
-                <a:tc>
-                  <a:txBody>
-                    <a:bodyPr/>
-                    <a:lstStyle/>
-                    <a:p>
-                      <a:pPr>
-                        <a:defRPr sz="1100">
-                          <a:solidFill>
-                            <a:srgbClr val="212529"/>
-                          </a:solidFill>
-                        </a:defRPr>
-                      </a:pPr>
-                      <a:r>
-                        <a:t>Edge Deployment Ready</a:t>
-                      </a:r>
-                    </a:p>
-                  </a:txBody>
-                  <a:tcPr>
-                    <a:solidFill>
-                      <a:srgbClr val="EBF1F8"/>
-                    </a:solidFill>
-                  </a:tcPr>
-                </a:tc>
-                <a:tc>
-                  <a:txBody>
-                    <a:bodyPr/>
-                    <a:lstStyle/>
-                    <a:p>
-                      <a:pPr>
-                        <a:defRPr sz="1100">
-                          <a:solidFill>
-                            <a:srgbClr val="212529"/>
-                          </a:solidFill>
-                        </a:defRPr>
-                      </a:pPr>
-                      <a:r>
-                        <a:t>Yes</a:t>
-                      </a:r>
-                    </a:p>
-                  </a:txBody>
-                  <a:tcPr>
-                    <a:solidFill>
-                      <a:srgbClr val="EBF1F8"/>
-                    </a:solidFill>
-                  </a:tcPr>
-                </a:tc>
-                <a:tc>
-                  <a:txBody>
-                    <a:bodyPr/>
-                    <a:lstStyle/>
-                    <a:p>
-                      <a:pPr>
-                        <a:defRPr sz="1100">
-                          <a:solidFill>
-                            <a:srgbClr val="212529"/>
-                          </a:solidFill>
-                        </a:defRPr>
-                      </a:pPr>
-                      <a:r>
-                        <a:t>Yes (with Attention)</a:t>
-                      </a:r>
-                    </a:p>
-                  </a:txBody>
-                  <a:tcPr>
-                    <a:solidFill>
-                      <a:srgbClr val="EBF1F8"/>
-                    </a:solidFill>
-                  </a:tcPr>
-                </a:tc>
-                <a:tc>
-                  <a:txBody>
-                    <a:bodyPr/>
-                    <a:lstStyle/>
-                    <a:p>
-                      <a:pPr>
-                        <a:defRPr sz="1100">
-                          <a:solidFill>
-                            <a:srgbClr val="212529"/>
-                          </a:solidFill>
-                        </a:defRPr>
-                      </a:pPr>
-                      <a:r>
-                        <a:t>No (Heavy Overhead)</a:t>
-                      </a:r>
-                    </a:p>
-                  </a:txBody>
-                  <a:tcPr>
-                    <a:solidFill>
-                      <a:srgbClr val="EBF1F8"/>
-                    </a:solidFill>
-                  </a:tcPr>
-                </a:tc>
-              </a:tr>
-              <a:tr h="438912">
-                <a:tc>
-                  <a:txBody>
-                    <a:bodyPr/>
-                    <a:lstStyle/>
-                    <a:p>
-                      <a:pPr>
-                        <a:defRPr sz="1100">
-                          <a:solidFill>
-                            <a:srgbClr val="212529"/>
-                          </a:solidFill>
-                        </a:defRPr>
-                      </a:pPr>
-                      <a:r>
-                        <a:t>XAI Visual Attribution</a:t>
+                        <a:t>69.05%</a:t>
                       </a:r>
                     </a:p>
                   </a:txBody>
@@ -8274,14 +8603,14 @@
                     <a:lstStyle/>
                     <a:p>
                       <a:pPr>
-                        <a:defRPr sz="1100">
+                        <a:defRPr sz="1000" b="0">
                           <a:solidFill>
                             <a:srgbClr val="212529"/>
                           </a:solidFill>
                         </a:defRPr>
                       </a:pPr>
                       <a:r>
-                        <a:t>Grad-CAM</a:t>
+                        <a:t>67.86%</a:t>
                       </a:r>
                     </a:p>
                   </a:txBody>
@@ -8297,37 +8626,14 @@
                     <a:lstStyle/>
                     <a:p>
                       <a:pPr>
-                        <a:defRPr sz="1100">
+                        <a:defRPr sz="1000" b="0">
                           <a:solidFill>
                             <a:srgbClr val="212529"/>
                           </a:solidFill>
                         </a:defRPr>
                       </a:pPr>
                       <a:r>
-                        <a:t>Grad-CAM + CBAM</a:t>
-                      </a:r>
-                    </a:p>
-                  </a:txBody>
-                  <a:tcPr>
-                    <a:solidFill>
-                      <a:srgbClr val="FFFFFF"/>
-                    </a:solidFill>
-                  </a:tcPr>
-                </a:tc>
-                <a:tc>
-                  <a:txBody>
-                    <a:bodyPr/>
-                    <a:lstStyle/>
-                    <a:p>
-                      <a:pPr>
-                        <a:defRPr sz="1100">
-                          <a:solidFill>
-                            <a:srgbClr val="212529"/>
-                          </a:solidFill>
-                        </a:defRPr>
-                      </a:pPr>
-                      <a:r>
-                        <a:t>Grad-CAM</a:t>
+                        <a:t>0.6732</a:t>
                       </a:r>
                     </a:p>
                   </a:txBody>

</xml_diff>